<commit_message>
docs: actualiza slide 12 con IP de produccion 3.238.70.143
</commit_message>
<xml_diff>
--- a/docs/Presentacion_SysMarket_Final.pptx
+++ b/docs/Presentacion_SysMarket_Final.pptx
@@ -7058,7 +7058,7 @@
                 </a:solidFill>
                 <a:latin typeface="Consolas"/>
               </a:rPr>
-              <a:t>http://&lt;IP_PUBLICA&gt;</a:t>
+              <a:t>http://3.238.70.143</a:t>
             </a:r>
           </a:p>
         </p:txBody>
@@ -7093,7 +7093,7 @@
                 </a:solidFill>
                 <a:latin typeface="Calibri"/>
               </a:rPr>
-              <a:t>👉 Actualizar con la IP del día de la exposición</a:t>
+              <a:t>✅ IP de produccion activa el dia de la exposicion</a:t>
             </a:r>
           </a:p>
         </p:txBody>

</xml_diff>

<commit_message>
docs: actualiza slide 12 con IP de produccion 98.93.36.34
</commit_message>
<xml_diff>
--- a/docs/Presentacion_SysMarket_Final.pptx
+++ b/docs/Presentacion_SysMarket_Final.pptx
@@ -4019,6 +4019,10 @@
             </a:stretch>
           </a:blipFill>
         </p:spPr>
+        <p:txBody>
+          <a:bodyPr/>
+          <a:p/>
+        </p:txBody>
       </p:sp>
       <p:sp>
         <p:nvSpPr>
@@ -9364,7 +9368,7 @@
                 <a:cs typeface="Consolas Bold"/>
                 <a:sym typeface="Consolas Bold"/>
               </a:rPr>
-              <a:t>http://&lt;IP_PUBLICA&gt;</a:t>
+              <a:t>http://98.93.36.34</a:t>
             </a:r>
           </a:p>
         </p:txBody>
@@ -9405,7 +9409,7 @@
                 <a:cs typeface="Calibri (MS) Italics"/>
                 <a:sym typeface="Calibri (MS) Italics"/>
               </a:rPr>
-              <a:t>👉 Actualizar con la IP del día de la exposición</a:t>
+              <a:t>URL de produccion activa para la exposicion del 27 de junio</a:t>
             </a:r>
           </a:p>
         </p:txBody>

</xml_diff>